<commit_message>
Audit Module 1: add missing Upcoming slide, remove on-slide timing labels and em dash
</commit_message>
<xml_diff>
--- a/Sports-Analytics-Undergraduate/01_Introduction_to_Basketball_Analytics/Lecture_Slides/Module_01_Introduction_to_Basketball_Analytics.pptx
+++ b/Sports-Analytics-Undergraduate/01_Introduction_to_Basketball_Analytics/Lecture_Slides/Module_01_Introduction_to_Basketball_Analytics.pptx
@@ -6,6 +6,7 @@
   </p:sldMasterIdLst>
   <p:sldIdLst>
     <p:sldId id="256" r:id="rId2"/>
+    <p:sldId id="290" r:id="rId41"/>
     <p:sldId id="257" r:id="rId3"/>
     <p:sldId id="258" r:id="rId4"/>
     <p:sldId id="259" r:id="rId5"/>
@@ -4126,7 +4127,7 @@
                 <a:ea typeface="Calibri" pitchFamily="34" charset="-122"/>
                 <a:cs typeface="Calibri" pitchFamily="34" charset="-120"/>
               </a:rPr>
-              <a:t>PRACTICE · THINK-PAIR-SHARE (5 MIN)</a:t>
+              <a:t>PRACTICE · THINK-PAIR-SHARE</a:t>
             </a:r>
             <a:endParaRPr lang="en-US" sz="1300" dirty="0"/>
           </a:p>
@@ -4192,6 +4193,10 @@
           </a:solidFill>
           <a:ln/>
         </p:spPr>
+        <p:txBody>
+          <a:bodyPr/>
+          <a:p/>
+        </p:txBody>
       </p:sp>
       <p:sp>
         <p:nvSpPr>
@@ -8197,6 +8202,10 @@
           </a:solidFill>
           <a:ln/>
         </p:spPr>
+        <p:txBody>
+          <a:bodyPr/>
+          <a:p/>
+        </p:txBody>
       </p:sp>
       <p:sp>
         <p:nvSpPr>
@@ -8296,7 +8305,7 @@
                 <a:ea typeface="Calibri" pitchFamily="34" charset="-122"/>
                 <a:cs typeface="Calibri" pitchFamily="34" charset="-120"/>
               </a:rPr>
-              <a:t>— FM</a:t>
+              <a:t>-FM</a:t>
             </a:r>
             <a:endParaRPr lang="en-US" sz="1600" dirty="0"/>
           </a:p>
@@ -8367,7 +8376,7 @@
                 <a:ea typeface="Calibri" pitchFamily="34" charset="-122"/>
                 <a:cs typeface="Calibri" pitchFamily="34" charset="-120"/>
               </a:rPr>
-              <a:t>INTERACTIVE ACTIVITY (8 MIN)</a:t>
+              <a:t>INTERACTIVE ACTIVITY</a:t>
             </a:r>
             <a:endParaRPr lang="en-US" sz="1300" dirty="0"/>
           </a:p>
@@ -8433,6 +8442,10 @@
           </a:solidFill>
           <a:ln/>
         </p:spPr>
+        <p:txBody>
+          <a:bodyPr/>
+          <a:p/>
+        </p:txBody>
       </p:sp>
       <p:sp>
         <p:nvSpPr>
@@ -8601,7 +8614,7 @@
                 <a:ea typeface="Calibri" pitchFamily="34" charset="-122"/>
                 <a:cs typeface="Calibri" pitchFamily="34" charset="-120"/>
               </a:rPr>
-              <a:t>PRACTICE (5 MIN)</a:t>
+              <a:t>PRACTICE</a:t>
             </a:r>
             <a:endParaRPr lang="en-US" sz="1300" dirty="0"/>
           </a:p>
@@ -8691,6 +8704,10 @@
           </a:solidFill>
           <a:ln/>
         </p:spPr>
+        <p:txBody>
+          <a:bodyPr/>
+          <a:p/>
+        </p:txBody>
       </p:sp>
       <p:sp>
         <p:nvSpPr>
@@ -10964,6 +10981,10 @@
           </a:solidFill>
           <a:ln/>
         </p:spPr>
+        <p:txBody>
+          <a:bodyPr/>
+          <a:p/>
+        </p:txBody>
       </p:sp>
       <p:sp>
         <p:nvSpPr>
@@ -11126,6 +11147,10 @@
           </a:solidFill>
           <a:ln/>
         </p:spPr>
+        <p:txBody>
+          <a:bodyPr/>
+          <a:p/>
+        </p:txBody>
       </p:sp>
       <p:sp>
         <p:nvSpPr>
@@ -11241,7 +11266,7 @@
                 <a:ea typeface="Calibri" pitchFamily="34" charset="-122"/>
                 <a:cs typeface="Calibri" pitchFamily="34" charset="-120"/>
               </a:rPr>
-              <a:t>Three segments, about three hours total:</a:t>
+              <a:t>Three segments today:</a:t>
             </a:r>
             <a:endParaRPr lang="en-US" sz="1200" dirty="0"/>
           </a:p>
@@ -11261,7 +11286,7 @@
                 <a:ea typeface="Calibri" pitchFamily="34" charset="-122"/>
                 <a:cs typeface="Calibri" pitchFamily="34" charset="-120"/>
               </a:rPr>
-              <a:t>Orientation (~45 min) → Worked Example (~60 min) → Five Throughlines (~45 min)</a:t>
+              <a:t>Orientation → Worked Example → Five Throughlines</a:t>
             </a:r>
             <a:endParaRPr lang="en-US" sz="1200" dirty="0"/>
           </a:p>
@@ -11288,6 +11313,10 @@
           </a:solidFill>
           <a:ln/>
         </p:spPr>
+        <p:txBody>
+          <a:bodyPr/>
+          <a:p/>
+        </p:txBody>
       </p:sp>
       <p:sp>
         <p:nvSpPr>
@@ -11430,6 +11459,10 @@
           </a:solidFill>
           <a:ln/>
         </p:spPr>
+        <p:txBody>
+          <a:bodyPr/>
+          <a:p/>
+        </p:txBody>
       </p:sp>
       <p:sp>
         <p:nvSpPr>
@@ -12940,6 +12973,444 @@
               <a:t>Pace, Ratings, and the Four Factors</a:t>
             </a:r>
             <a:endParaRPr lang="en-US" sz="1800" dirty="0"/>
+          </a:p>
+        </p:txBody>
+      </p:sp>
+    </p:spTree>
+  </p:cSld>
+  <p:clrMapOvr>
+    <a:masterClrMapping/>
+  </p:clrMapOvr>
+</p:sld>
+</file>
+
+<file path=ppt/slides/slide35.xml><?xml version="1.0" encoding="utf-8"?>
+<p:sld xmlns:a="http://schemas.openxmlformats.org/drawingml/2006/main" xmlns:p="http://schemas.openxmlformats.org/presentationml/2006/main" xmlns:r="http://schemas.openxmlformats.org/officeDocument/2006/relationships">
+  <p:cSld>
+    <p:bg>
+      <p:bgPr>
+        <a:solidFill>
+          <a:srgbClr val="FFFFFF"/>
+        </a:solidFill>
+        <a:effectLst/>
+      </p:bgPr>
+    </p:bg>
+    <p:spTree>
+      <p:nvGrpSpPr>
+        <p:cNvPr id="1" name=""/>
+        <p:cNvGrpSpPr/>
+        <p:nvPr/>
+      </p:nvGrpSpPr>
+      <p:grpSpPr/>
+      <p:sp>
+        <p:nvSpPr>
+          <p:cNvPr id="2" name="TextBox 1"/>
+          <p:cNvSpPr txBox="1"/>
+          <p:nvPr/>
+        </p:nvSpPr>
+        <p:spPr>
+          <a:xfrm>
+            <a:off x="548640" y="411480"/>
+            <a:ext cx="11091672" cy="320040"/>
+          </a:xfrm>
+          <a:prstGeom prst="rect">
+            <a:avLst/>
+          </a:prstGeom>
+          <a:noFill/>
+        </p:spPr>
+        <p:txBody>
+          <a:bodyPr wrap="square" lIns="0" rIns="0" tIns="0" bIns="0" anchor="t">
+            <a:spAutoFit/>
+          </a:bodyPr>
+          <a:lstStyle/>
+          <a:p>
+            <a:pPr algn="l"/>
+            <a:r>
+              <a:rPr sz="1300" b="1" i="0">
+                <a:solidFill>
+                  <a:srgbClr val="E4572E"/>
+                </a:solidFill>
+                <a:latin typeface="Calibri"/>
+              </a:rPr>
+              <a:t>BEFORE WE START</a:t>
+            </a:r>
+          </a:p>
+        </p:txBody>
+      </p:sp>
+      <p:sp>
+        <p:nvSpPr>
+          <p:cNvPr id="3" name="TextBox 2"/>
+          <p:cNvSpPr txBox="1"/>
+          <p:nvPr/>
+        </p:nvSpPr>
+        <p:spPr>
+          <a:xfrm>
+            <a:off x="548640" y="960120"/>
+            <a:ext cx="11091672" cy="822960"/>
+          </a:xfrm>
+          <a:prstGeom prst="rect">
+            <a:avLst/>
+          </a:prstGeom>
+          <a:noFill/>
+        </p:spPr>
+        <p:txBody>
+          <a:bodyPr wrap="square" lIns="0" rIns="0" tIns="0" bIns="0" anchor="t">
+            <a:spAutoFit/>
+          </a:bodyPr>
+          <a:lstStyle/>
+          <a:p>
+            <a:pPr algn="l"/>
+            <a:r>
+              <a:rPr sz="3000" b="1" i="0">
+                <a:solidFill>
+                  <a:srgbClr val="16213E"/>
+                </a:solidFill>
+                <a:latin typeface="Cambria"/>
+              </a:rPr>
+              <a:t>What's Coming Up</a:t>
+            </a:r>
+          </a:p>
+        </p:txBody>
+      </p:sp>
+      <p:sp>
+        <p:nvSpPr>
+          <p:cNvPr id="4" name="Rounded Rectangle 3"/>
+          <p:cNvSpPr/>
+          <p:nvPr/>
+        </p:nvSpPr>
+        <p:spPr>
+          <a:xfrm>
+            <a:off x="548640" y="2011680"/>
+            <a:ext cx="11091672" cy="1051560"/>
+          </a:xfrm>
+          <a:prstGeom prst="roundRect">
+            <a:avLst/>
+          </a:prstGeom>
+          <a:solidFill>
+            <a:srgbClr val="EDF1F7"/>
+          </a:solidFill>
+          <a:ln>
+            <a:noFill/>
+          </a:ln>
+          <a:effectLst/>
+        </p:spPr>
+        <p:style>
+          <a:lnRef idx="1">
+            <a:schemeClr val="accent1"/>
+          </a:lnRef>
+          <a:fillRef idx="3">
+            <a:schemeClr val="accent1"/>
+          </a:fillRef>
+          <a:effectRef idx="2">
+            <a:schemeClr val="accent1"/>
+          </a:effectRef>
+          <a:fontRef idx="minor">
+            <a:schemeClr val="lt1"/>
+          </a:fontRef>
+        </p:style>
+        <p:txBody>
+          <a:bodyPr rtlCol="0" anchor="ctr"/>
+          <a:lstStyle/>
+          <a:p>
+            <a:pPr algn="ctr"/>
+          </a:p>
+        </p:txBody>
+      </p:sp>
+      <p:sp>
+        <p:nvSpPr>
+          <p:cNvPr id="5" name="TextBox 4"/>
+          <p:cNvSpPr txBox="1"/>
+          <p:nvPr/>
+        </p:nvSpPr>
+        <p:spPr>
+          <a:xfrm>
+            <a:off x="822960" y="2011680"/>
+            <a:ext cx="2560320" cy="1051560"/>
+          </a:xfrm>
+          <a:prstGeom prst="rect">
+            <a:avLst/>
+          </a:prstGeom>
+          <a:noFill/>
+        </p:spPr>
+        <p:txBody>
+          <a:bodyPr wrap="square" lIns="0" rIns="0" tIns="0" bIns="0" anchor="ctr">
+            <a:spAutoFit/>
+          </a:bodyPr>
+          <a:lstStyle/>
+          <a:p>
+            <a:pPr algn="l"/>
+            <a:r>
+              <a:rPr sz="1500" b="1" i="0">
+                <a:solidFill>
+                  <a:srgbClr val="27496D"/>
+                </a:solidFill>
+                <a:latin typeface="Calibri"/>
+              </a:rPr>
+              <a:t>Due This Week</a:t>
+            </a:r>
+          </a:p>
+        </p:txBody>
+      </p:sp>
+      <p:sp>
+        <p:nvSpPr>
+          <p:cNvPr id="6" name="TextBox 5"/>
+          <p:cNvSpPr txBox="1"/>
+          <p:nvPr/>
+        </p:nvSpPr>
+        <p:spPr>
+          <a:xfrm>
+            <a:off x="3566160" y="2011680"/>
+            <a:ext cx="7315200" cy="1051560"/>
+          </a:xfrm>
+          <a:prstGeom prst="rect">
+            <a:avLst/>
+          </a:prstGeom>
+          <a:noFill/>
+        </p:spPr>
+        <p:txBody>
+          <a:bodyPr wrap="square" lIns="0" rIns="0" tIns="0" bIns="0" anchor="ctr">
+            <a:spAutoFit/>
+          </a:bodyPr>
+          <a:lstStyle/>
+          <a:p>
+            <a:pPr algn="l"/>
+            <a:r>
+              <a:rPr sz="1400" b="0" i="1">
+                <a:solidFill>
+                  <a:srgbClr val="6B7A99"/>
+                </a:solidFill>
+                <a:latin typeface="Calibri"/>
+              </a:rPr>
+              <a:t>-- update before class --</a:t>
+            </a:r>
+          </a:p>
+        </p:txBody>
+      </p:sp>
+      <p:sp>
+        <p:nvSpPr>
+          <p:cNvPr id="7" name="Rounded Rectangle 6"/>
+          <p:cNvSpPr/>
+          <p:nvPr/>
+        </p:nvSpPr>
+        <p:spPr>
+          <a:xfrm>
+            <a:off x="548640" y="3246120"/>
+            <a:ext cx="11091672" cy="1051560"/>
+          </a:xfrm>
+          <a:prstGeom prst="roundRect">
+            <a:avLst/>
+          </a:prstGeom>
+          <a:solidFill>
+            <a:srgbClr val="EDF1F7"/>
+          </a:solidFill>
+          <a:ln>
+            <a:noFill/>
+          </a:ln>
+          <a:effectLst/>
+        </p:spPr>
+        <p:style>
+          <a:lnRef idx="1">
+            <a:schemeClr val="accent1"/>
+          </a:lnRef>
+          <a:fillRef idx="3">
+            <a:schemeClr val="accent1"/>
+          </a:fillRef>
+          <a:effectRef idx="2">
+            <a:schemeClr val="accent1"/>
+          </a:effectRef>
+          <a:fontRef idx="minor">
+            <a:schemeClr val="lt1"/>
+          </a:fontRef>
+        </p:style>
+        <p:txBody>
+          <a:bodyPr rtlCol="0" anchor="ctr"/>
+          <a:lstStyle/>
+          <a:p>
+            <a:pPr algn="ctr"/>
+          </a:p>
+        </p:txBody>
+      </p:sp>
+      <p:sp>
+        <p:nvSpPr>
+          <p:cNvPr id="8" name="TextBox 7"/>
+          <p:cNvSpPr txBox="1"/>
+          <p:nvPr/>
+        </p:nvSpPr>
+        <p:spPr>
+          <a:xfrm>
+            <a:off x="822960" y="3246120"/>
+            <a:ext cx="2560320" cy="1051560"/>
+          </a:xfrm>
+          <a:prstGeom prst="rect">
+            <a:avLst/>
+          </a:prstGeom>
+          <a:noFill/>
+        </p:spPr>
+        <p:txBody>
+          <a:bodyPr wrap="square" lIns="0" rIns="0" tIns="0" bIns="0" anchor="ctr">
+            <a:spAutoFit/>
+          </a:bodyPr>
+          <a:lstStyle/>
+          <a:p>
+            <a:pPr algn="l"/>
+            <a:r>
+              <a:rPr sz="1500" b="1" i="0">
+                <a:solidFill>
+                  <a:srgbClr val="27496D"/>
+                </a:solidFill>
+                <a:latin typeface="Calibri"/>
+              </a:rPr>
+              <a:t>Coming Up</a:t>
+            </a:r>
+          </a:p>
+        </p:txBody>
+      </p:sp>
+      <p:sp>
+        <p:nvSpPr>
+          <p:cNvPr id="9" name="TextBox 8"/>
+          <p:cNvSpPr txBox="1"/>
+          <p:nvPr/>
+        </p:nvSpPr>
+        <p:spPr>
+          <a:xfrm>
+            <a:off x="3566160" y="3246120"/>
+            <a:ext cx="7315200" cy="1051560"/>
+          </a:xfrm>
+          <a:prstGeom prst="rect">
+            <a:avLst/>
+          </a:prstGeom>
+          <a:noFill/>
+        </p:spPr>
+        <p:txBody>
+          <a:bodyPr wrap="square" lIns="0" rIns="0" tIns="0" bIns="0" anchor="ctr">
+            <a:spAutoFit/>
+          </a:bodyPr>
+          <a:lstStyle/>
+          <a:p>
+            <a:pPr algn="l"/>
+            <a:r>
+              <a:rPr sz="1400" b="0" i="1">
+                <a:solidFill>
+                  <a:srgbClr val="6B7A99"/>
+                </a:solidFill>
+                <a:latin typeface="Calibri"/>
+              </a:rPr>
+              <a:t>-- update before class --</a:t>
+            </a:r>
+          </a:p>
+        </p:txBody>
+      </p:sp>
+      <p:sp>
+        <p:nvSpPr>
+          <p:cNvPr id="10" name="Rounded Rectangle 9"/>
+          <p:cNvSpPr/>
+          <p:nvPr/>
+        </p:nvSpPr>
+        <p:spPr>
+          <a:xfrm>
+            <a:off x="548640" y="4480560"/>
+            <a:ext cx="11091672" cy="1051560"/>
+          </a:xfrm>
+          <a:prstGeom prst="roundRect">
+            <a:avLst/>
+          </a:prstGeom>
+          <a:solidFill>
+            <a:srgbClr val="EDF1F7"/>
+          </a:solidFill>
+          <a:ln>
+            <a:noFill/>
+          </a:ln>
+          <a:effectLst/>
+        </p:spPr>
+        <p:style>
+          <a:lnRef idx="1">
+            <a:schemeClr val="accent1"/>
+          </a:lnRef>
+          <a:fillRef idx="3">
+            <a:schemeClr val="accent1"/>
+          </a:fillRef>
+          <a:effectRef idx="2">
+            <a:schemeClr val="accent1"/>
+          </a:effectRef>
+          <a:fontRef idx="minor">
+            <a:schemeClr val="lt1"/>
+          </a:fontRef>
+        </p:style>
+        <p:txBody>
+          <a:bodyPr rtlCol="0" anchor="ctr"/>
+          <a:lstStyle/>
+          <a:p>
+            <a:pPr algn="ctr"/>
+          </a:p>
+        </p:txBody>
+      </p:sp>
+      <p:sp>
+        <p:nvSpPr>
+          <p:cNvPr id="11" name="TextBox 10"/>
+          <p:cNvSpPr txBox="1"/>
+          <p:nvPr/>
+        </p:nvSpPr>
+        <p:spPr>
+          <a:xfrm>
+            <a:off x="822960" y="4480560"/>
+            <a:ext cx="2560320" cy="1051560"/>
+          </a:xfrm>
+          <a:prstGeom prst="rect">
+            <a:avLst/>
+          </a:prstGeom>
+          <a:noFill/>
+        </p:spPr>
+        <p:txBody>
+          <a:bodyPr wrap="square" lIns="0" rIns="0" tIns="0" bIns="0" anchor="ctr">
+            <a:spAutoFit/>
+          </a:bodyPr>
+          <a:lstStyle/>
+          <a:p>
+            <a:pPr algn="l"/>
+            <a:r>
+              <a:rPr sz="1500" b="1" i="0">
+                <a:solidFill>
+                  <a:srgbClr val="27496D"/>
+                </a:solidFill>
+                <a:latin typeface="Calibri"/>
+              </a:rPr>
+              <a:t>Office Hours</a:t>
+            </a:r>
+          </a:p>
+        </p:txBody>
+      </p:sp>
+      <p:sp>
+        <p:nvSpPr>
+          <p:cNvPr id="12" name="TextBox 11"/>
+          <p:cNvSpPr txBox="1"/>
+          <p:nvPr/>
+        </p:nvSpPr>
+        <p:spPr>
+          <a:xfrm>
+            <a:off x="3566160" y="4480560"/>
+            <a:ext cx="7315200" cy="1051560"/>
+          </a:xfrm>
+          <a:prstGeom prst="rect">
+            <a:avLst/>
+          </a:prstGeom>
+          <a:noFill/>
+        </p:spPr>
+        <p:txBody>
+          <a:bodyPr wrap="square" lIns="0" rIns="0" tIns="0" bIns="0" anchor="ctr">
+            <a:spAutoFit/>
+          </a:bodyPr>
+          <a:lstStyle/>
+          <a:p>
+            <a:pPr algn="l"/>
+            <a:r>
+              <a:rPr sz="1400" b="0" i="1">
+                <a:solidFill>
+                  <a:srgbClr val="6B7A99"/>
+                </a:solidFill>
+                <a:latin typeface="Calibri"/>
+              </a:rPr>
+              <a:t>-- update before class --</a:t>
+            </a:r>
           </a:p>
         </p:txBody>
       </p:sp>

</xml_diff>